<commit_message>
Agent reasoning box, business model, real app screenshots on the site
Co-Authored-By: Claude Sonnet 5.5 <noreply@anthropic.com>
</commit_message>
<xml_diff>
--- a/PayPilot_pitch.pptx
+++ b/PayPilot_pitch.pptx
@@ -12,6 +12,7 @@
     <p:sldId id="260" r:id="rId11"/>
     <p:sldId id="261" r:id="rId12"/>
     <p:sldId id="262" r:id="rId13"/>
+    <p:sldId id="263" r:id="rId14"/>
   </p:sldIdLst>
   <p:sldSz cx="12191695" cy="6858000" type="screen4x3"/>
   <p:notesSz cx="6858000" cy="9144000"/>
@@ -4374,6 +4375,243 @@
 </file>
 
 <file path=ppt/slides/slide7.xml><?xml version="1.0" encoding="utf-8"?>
+<p:sld xmlns:a="http://schemas.openxmlformats.org/drawingml/2006/main" xmlns:p="http://schemas.openxmlformats.org/presentationml/2006/main" xmlns:r="http://schemas.openxmlformats.org/officeDocument/2006/relationships">
+  <p:cSld>
+    <p:bg>
+      <p:bgPr>
+        <a:solidFill>
+          <a:srgbClr val="0B1F3A"/>
+        </a:solidFill>
+        <a:effectLst/>
+      </p:bgPr>
+    </p:bg>
+    <p:spTree>
+      <p:nvGrpSpPr>
+        <p:cNvPr id="1" name=""/>
+        <p:cNvGrpSpPr/>
+        <p:nvPr/>
+      </p:nvGrpSpPr>
+      <p:grpSpPr/>
+      <p:sp>
+        <p:nvSpPr>
+          <p:cNvPr id="2" name="Rectangle 1"/>
+          <p:cNvSpPr/>
+          <p:nvPr/>
+        </p:nvSpPr>
+        <p:spPr>
+          <a:xfrm>
+            <a:off x="0" y="0"/>
+            <a:ext cx="228600" cy="6858000"/>
+          </a:xfrm>
+          <a:prstGeom prst="rect">
+            <a:avLst/>
+          </a:prstGeom>
+          <a:solidFill>
+            <a:srgbClr val="1FC8B4"/>
+          </a:solidFill>
+          <a:ln>
+            <a:noFill/>
+          </a:ln>
+        </p:spPr>
+        <p:style>
+          <a:lnRef idx="1">
+            <a:schemeClr val="accent1"/>
+          </a:lnRef>
+          <a:fillRef idx="3">
+            <a:schemeClr val="accent1"/>
+          </a:fillRef>
+          <a:effectRef idx="2">
+            <a:schemeClr val="accent1"/>
+          </a:effectRef>
+          <a:fontRef idx="minor">
+            <a:schemeClr val="lt1"/>
+          </a:fontRef>
+        </p:style>
+        <p:txBody>
+          <a:bodyPr rtlCol="0" anchor="ctr"/>
+          <a:lstStyle/>
+          <a:p>
+            <a:pPr algn="ctr"/>
+          </a:p>
+        </p:txBody>
+      </p:sp>
+      <p:sp>
+        <p:nvSpPr>
+          <p:cNvPr id="3" name="TextBox 2"/>
+          <p:cNvSpPr txBox="1"/>
+          <p:nvPr/>
+        </p:nvSpPr>
+        <p:spPr>
+          <a:xfrm>
+            <a:off x="731520" y="457200"/>
+            <a:ext cx="10698480" cy="1280160"/>
+          </a:xfrm>
+          <a:prstGeom prst="rect">
+            <a:avLst/>
+          </a:prstGeom>
+          <a:noFill/>
+        </p:spPr>
+        <p:txBody>
+          <a:bodyPr wrap="none">
+            <a:spAutoFit/>
+          </a:bodyPr>
+          <a:lstStyle/>
+          <a:p>
+            <a:pPr>
+              <a:defRPr sz="3800" b="1">
+                <a:solidFill>
+                  <a:srgbClr val="FFFFFF"/>
+                </a:solidFill>
+              </a:defRPr>
+            </a:pPr>
+            <a:r>
+              <a:t>Business model</a:t>
+            </a:r>
+          </a:p>
+        </p:txBody>
+      </p:sp>
+      <p:sp>
+        <p:nvSpPr>
+          <p:cNvPr id="4" name="TextBox 3"/>
+          <p:cNvSpPr txBox="1"/>
+          <p:nvPr/>
+        </p:nvSpPr>
+        <p:spPr>
+          <a:xfrm>
+            <a:off x="731520" y="1371600"/>
+            <a:ext cx="10698480" cy="914400"/>
+          </a:xfrm>
+          <a:prstGeom prst="rect">
+            <a:avLst/>
+          </a:prstGeom>
+          <a:noFill/>
+        </p:spPr>
+        <p:txBody>
+          <a:bodyPr wrap="none">
+            <a:spAutoFit/>
+          </a:bodyPr>
+          <a:lstStyle/>
+          <a:p>
+            <a:pPr>
+              <a:defRPr sz="2400">
+                <a:solidFill>
+                  <a:srgbClr val="1FC8B4"/>
+                </a:solidFill>
+              </a:defRPr>
+            </a:pPr>
+            <a:r>
+              <a:t>Simple, affordable, easy to try</a:t>
+            </a:r>
+          </a:p>
+        </p:txBody>
+      </p:sp>
+      <p:sp>
+        <p:nvSpPr>
+          <p:cNvPr id="5" name="TextBox 4"/>
+          <p:cNvSpPr txBox="1"/>
+          <p:nvPr/>
+        </p:nvSpPr>
+        <p:spPr>
+          <a:xfrm>
+            <a:off x="731520" y="1920240"/>
+            <a:ext cx="10698480" cy="4389120"/>
+          </a:xfrm>
+          <a:prstGeom prst="rect">
+            <a:avLst/>
+          </a:prstGeom>
+          <a:noFill/>
+        </p:spPr>
+        <p:txBody>
+          <a:bodyPr wrap="square">
+            <a:spAutoFit/>
+          </a:bodyPr>
+          <a:lstStyle/>
+          <a:p>
+            <a:pPr>
+              <a:spcAft>
+                <a:spcPts val="1400"/>
+              </a:spcAft>
+              <a:defRPr sz="2600">
+                <a:solidFill>
+                  <a:srgbClr val="FFFFFF"/>
+                </a:solidFill>
+              </a:defRPr>
+            </a:pPr>
+            <a:r>
+              <a:t>•  Who: small UAE businesses that invoice on credit (trading, catering, services)</a:t>
+            </a:r>
+          </a:p>
+          <a:p>
+            <a:pPr>
+              <a:spcAft>
+                <a:spcPts val="1400"/>
+              </a:spcAft>
+              <a:defRPr sz="2600">
+                <a:solidFill>
+                  <a:srgbClr val="FFFFFF"/>
+                </a:solidFill>
+              </a:defRPr>
+            </a:pPr>
+            <a:r>
+              <a:t>•  Price (proposed): AED 99 per month per business</a:t>
+            </a:r>
+          </a:p>
+          <a:p>
+            <a:pPr>
+              <a:spcAft>
+                <a:spcPts val="1400"/>
+              </a:spcAft>
+              <a:defRPr sz="2600">
+                <a:solidFill>
+                  <a:srgbClr val="FFFFFF"/>
+                </a:solidFill>
+              </a:defRPr>
+            </a:pPr>
+            <a:r>
+              <a:t>•  One recovered AED 3,000 invoice pays for the whole year</a:t>
+            </a:r>
+          </a:p>
+          <a:p>
+            <a:pPr>
+              <a:spcAft>
+                <a:spcPts val="1400"/>
+              </a:spcAft>
+              <a:defRPr sz="2600">
+                <a:solidFill>
+                  <a:srgbClr val="FFFFFF"/>
+                </a:solidFill>
+              </a:defRPr>
+            </a:pPr>
+            <a:r>
+              <a:t>•  Low cost to run: the agent only drafts, the owner approves in seconds</a:t>
+            </a:r>
+          </a:p>
+          <a:p>
+            <a:pPr>
+              <a:spcAft>
+                <a:spcPts val="1400"/>
+              </a:spcAft>
+              <a:defRPr sz="2600">
+                <a:solidFill>
+                  <a:srgbClr val="FFFFFF"/>
+                </a:solidFill>
+              </a:defRPr>
+            </a:pPr>
+            <a:r>
+              <a:t>•  Later: pay-per-recovery option and accountant partnerships</a:t>
+            </a:r>
+          </a:p>
+        </p:txBody>
+      </p:sp>
+    </p:spTree>
+  </p:cSld>
+  <p:clrMapOvr>
+    <a:masterClrMapping/>
+  </p:clrMapOvr>
+</p:sld>
+</file>
+
+<file path=ppt/slides/slide8.xml><?xml version="1.0" encoding="utf-8"?>
 <p:sld xmlns:a="http://schemas.openxmlformats.org/drawingml/2006/main" xmlns:p="http://schemas.openxmlformats.org/presentationml/2006/main" xmlns:r="http://schemas.openxmlformats.org/officeDocument/2006/relationships">
   <p:cSld>
     <p:bg>

</xml_diff>